<commit_message>
Onderzoekssamenvatting: gedachtestrepen verwijderd; PDF-versie toegevoegd
Co-Authored-By: Claude Fable 5 <noreply@anthropic.com>
Claude-Session: https://claude.ai/code/session_01LyHqXebCLUUs7NcaQcRSUZ
</commit_message>
<xml_diff>
--- a/MIT-28436/communicatie/Onderzoekssamenvatting_AgenticAI_Inclufy.pptx
+++ b/MIT-28436/communicatie/Onderzoekssamenvatting_AgenticAI_Inclufy.pptx
@@ -1936,7 +1936,7 @@
                 <a:ea typeface="Calibri" pitchFamily="34" charset="-122"/>
                 <a:cs typeface="Calibri" pitchFamily="34" charset="-120"/>
               </a:rPr>
-              <a:t>Is er bij het Nederlandse MKB voldoende behoefte aan en betalingsbereidheid voor AI-agents die zelfstandig taken uitvoeren in projectmanagement en marketing — en zo ja: in welke sectoren, tegen welk prijsmodel, onder welke juridische voorwaarden?</a:t>
+              <a:t>Is er bij het Nederlandse MKB voldoende behoefte aan en betalingsbereidheid voor AI-agents die zelfstandig taken uitvoeren in projectmanagement en marketing, en zo ja: in welke sectoren, tegen welk prijsmodel, onder welke juridische voorwaarden?</a:t>
             </a:r>
             <a:endParaRPr lang="en-US" sz="1550" dirty="0"/>
           </a:p>
@@ -3615,7 +3615,7 @@
                 <a:ea typeface="Calibri" pitchFamily="34" charset="-122"/>
                 <a:cs typeface="Calibri" pitchFamily="34" charset="-120"/>
               </a:rPr>
-              <a:t>Halverwege — veldwerk versnelt, harde mijlpalen in zicht</a:t>
+              <a:t>Halverwege: veldwerk versnelt, harde mijlpalen in zicht</a:t>
             </a:r>
             <a:endParaRPr lang="en-US" sz="1400" dirty="0"/>
           </a:p>
@@ -4020,7 +4020,7 @@
                 <a:ea typeface="Calibri" pitchFamily="34" charset="-122"/>
                 <a:cs typeface="Calibri" pitchFamily="34" charset="-120"/>
               </a:rPr>
-              <a:t>Survey-analyse · technische PoC en MAPE-benchmark · conceptvalidatie bij 5 testbedrijven — harde mijlpaal 30 nov</a:t>
+              <a:t>Survey-analyse · technische PoC en MAPE-benchmark · conceptvalidatie bij 5 testbedrijven; harde mijlpaal 30 nov</a:t>
             </a:r>
             <a:endParaRPr lang="en-US" sz="1250" dirty="0"/>
           </a:p>
@@ -4425,7 +4425,7 @@
                 <a:ea typeface="Calibri" pitchFamily="34" charset="-122"/>
                 <a:cs typeface="Calibri" pitchFamily="34" charset="-120"/>
               </a:rPr>
-              <a:t>Whitepaper — "Juridische kaders voor agentic AI in het MKB"</a:t>
+              <a:t>Whitepaper: "Juridische kaders voor agentic AI in het MKB"</a:t>
             </a:r>
             <a:endParaRPr lang="en-US" sz="1550" dirty="0"/>
           </a:p>
@@ -4674,7 +4674,7 @@
                 <a:ea typeface="Calibri" pitchFamily="34" charset="-122"/>
                 <a:cs typeface="Calibri" pitchFamily="34" charset="-120"/>
               </a:rPr>
-              <a:t>Geanonimiseerde, gebundelde interviewbevindingen die de governance-lesmodule van ROC / House of Digital voeden — gebouwd op de modulestructuur van AI &amp; Partners.</a:t>
+              <a:t>Geanonimiseerde, gebundelde interviewbevindingen die de governance-lesmodule van ROC / House of Digital voeden, gebouwd op de modulestructuur van AI &amp; Partners.</a:t>
             </a:r>
             <a:endParaRPr lang="en-US" sz="1200" dirty="0"/>
           </a:p>
@@ -4862,7 +4862,7 @@
                 <a:ea typeface="Calibri" pitchFamily="34" charset="-122"/>
                 <a:cs typeface="Calibri" pitchFamily="34" charset="-120"/>
               </a:rPr>
-              <a:t>Vier rollen — drie op kennisdeling, één via de offerteprocedure</a:t>
+              <a:t>Vier rollen: drie op kennisdeling, één via de offerteprocedure</a:t>
             </a:r>
             <a:endParaRPr lang="en-US" sz="1400" dirty="0"/>
           </a:p>
@@ -5711,7 +5711,7 @@
                 <a:ea typeface="Calibri" pitchFamily="34" charset="-122"/>
                 <a:cs typeface="Calibri" pitchFamily="34" charset="-120"/>
               </a:rPr>
-              <a:t>Onderzoeksopzet, analyse en conclusies blijven bij Inclufy. De ML-opdracht wordt gegund via een gedocumenteerde offerteprocedure — een voorwaarde van de subsidie.</a:t>
+              <a:t>Onderzoeksopzet, analyse en conclusies blijven bij Inclufy. De ML-opdracht wordt gegund via een gedocumenteerde offerteprocedure, een voorwaarde van de subsidie.</a:t>
             </a:r>
             <a:endParaRPr lang="en-US" sz="1200" dirty="0"/>
           </a:p>
@@ -5811,7 +5811,7 @@
                 <a:ea typeface="Calibri" pitchFamily="34" charset="-122"/>
                 <a:cs typeface="Calibri" pitchFamily="34" charset="-120"/>
               </a:rPr>
-              <a:t>Interviewdata wordt uitsluitend geanonimiseerd en gebundeld gedeeld — nooit transcripten, namen of herleidbare bedrijfsinformatie.</a:t>
+              <a:t>Interviewdata wordt uitsluitend geanonimiseerd en gebundeld gedeeld: nooit transcripten, namen of herleidbare bedrijfsinformatie.</a:t>
             </a:r>
             <a:endParaRPr lang="en-US" sz="1200" dirty="0"/>
           </a:p>
@@ -5911,7 +5911,7 @@
                 <a:ea typeface="Calibri" pitchFamily="34" charset="-122"/>
                 <a:cs typeface="Calibri" pitchFamily="34" charset="-120"/>
               </a:rPr>
-              <a:t>De onafhankelijke technische toets betreft het concept en de aanpak (transfer learning, meetprotocol) — geen beoordeling van de eigen applicatie van Inclufy.</a:t>
+              <a:t>De onafhankelijke technische toets betreft het concept en de aanpak (transfer learning, meetprotocol); geen beoordeling van de eigen applicatie van Inclufy.</a:t>
             </a:r>
             <a:endParaRPr lang="en-US" sz="1200" dirty="0"/>
           </a:p>
@@ -6050,7 +6050,7 @@
                 <a:ea typeface="Calibri" pitchFamily="34" charset="-122"/>
                 <a:cs typeface="Calibri" pitchFamily="34" charset="-120"/>
               </a:rPr>
-              <a:t>Sami Loukile · sami@inclufy.com · 06 39456320 — Mede mogelijk gemaakt door een subsidie van de provincie Flevoland</a:t>
+              <a:t>Sami Loukile · sami@inclufy.com · 06 39456320 · Mede mogelijk gemaakt door een subsidie van de provincie Flevoland</a:t>
             </a:r>
             <a:endParaRPr lang="en-US" sz="1100" dirty="0"/>
           </a:p>

</xml_diff>